<commit_message>
deploy: 2026-07-07 19:41 (build 20260707194149)
</commit_message>
<xml_diff>
--- a/cloudflare-deploy/public/library/admin/admin-en.pptx
+++ b/cloudflare-deploy/public/library/admin/admin-en.pptx
@@ -4062,7 +4062,7 @@
                 </a:solidFill>
                 <a:latin typeface="Malgun Gothic"/>
               </a:rPr>
-              <a:t>For · Academy directors · HQ · operations managers   |   test.mangoi.co.kr</a:t>
+              <a:t>For · Academy directors · HQ · operations managers   |   www.mangoi.co.kr</a:t>
             </a:r>
           </a:p>
         </p:txBody>
@@ -28050,7 +28050,7 @@
                 </a:solidFill>
                 <a:latin typeface="Malgun Gothic"/>
               </a:rPr>
-              <a:t>🌐 test.mangoi.co.kr    📞 1588-0000    ✉ support@mangoi.co.kr</a:t>
+              <a:t>🌐 www.mangoi.co.kr    📞 1644-0561    ✉ support@mangoi.co.kr</a:t>
             </a:r>
           </a:p>
         </p:txBody>

</xml_diff>

<commit_message>
deploy: 2026-07-10 15:46 (build 20260710154631)
</commit_message>
<xml_diff>
--- a/cloudflare-deploy/public/library/admin/admin-en.pptx
+++ b/cloudflare-deploy/public/library/admin/admin-en.pptx
@@ -6,6 +6,7 @@
   </p:sldMasterIdLst>
   <p:sldIdLst>
     <p:sldId id="256" r:id="rId7"/>
+    <p:sldId id="289" r:id="rId40"/>
     <p:sldId id="257" r:id="rId8"/>
     <p:sldId id="258" r:id="rId9"/>
     <p:sldId id="259" r:id="rId10"/>
@@ -22540,7 +22541,7 @@
         </p:nvSpPr>
         <p:spPr>
           <a:xfrm>
-            <a:off x="365760" y="868680"/>
+            <a:off x="987552" y="868680"/>
             <a:ext cx="9144000" cy="457200"/>
           </a:xfrm>
           <a:prstGeom prst="rect">
@@ -23257,6 +23258,89 @@
           </a:graphicData>
         </a:graphic>
       </p:graphicFrame>
+      <p:sp>
+        <p:nvSpPr>
+          <p:cNvPr id="6" name="Rounded Rectangle 5"/>
+          <p:cNvSpPr/>
+          <p:nvPr/>
+        </p:nvSpPr>
+        <p:spPr>
+          <a:xfrm>
+            <a:off x="365760" y="841247"/>
+            <a:ext cx="475488" cy="475488"/>
+          </a:xfrm>
+          <a:prstGeom prst="roundRect">
+            <a:avLst/>
+          </a:prstGeom>
+          <a:solidFill>
+            <a:srgbClr val="4F46E5"/>
+          </a:solidFill>
+          <a:ln>
+            <a:noFill/>
+          </a:ln>
+          <a:effectLst/>
+        </p:spPr>
+        <p:style>
+          <a:lnRef idx="1">
+            <a:schemeClr val="accent1"/>
+          </a:lnRef>
+          <a:fillRef idx="3">
+            <a:schemeClr val="accent1"/>
+          </a:fillRef>
+          <a:effectRef idx="2">
+            <a:schemeClr val="accent1"/>
+          </a:effectRef>
+          <a:fontRef idx="minor">
+            <a:schemeClr val="lt1"/>
+          </a:fontRef>
+        </p:style>
+        <p:txBody>
+          <a:bodyPr rtlCol="0" anchor="ctr"/>
+          <a:lstStyle/>
+          <a:p>
+            <a:pPr algn="ctr"/>
+          </a:p>
+        </p:txBody>
+      </p:sp>
+      <p:sp>
+        <p:nvSpPr>
+          <p:cNvPr id="7" name="TextBox 6"/>
+          <p:cNvSpPr txBox="1"/>
+          <p:nvPr/>
+        </p:nvSpPr>
+        <p:spPr>
+          <a:xfrm>
+            <a:off x="365760" y="841247"/>
+            <a:ext cx="475488" cy="475488"/>
+          </a:xfrm>
+          <a:prstGeom prst="rect">
+            <a:avLst/>
+          </a:prstGeom>
+          <a:noFill/>
+        </p:spPr>
+        <p:txBody>
+          <a:bodyPr wrap="square" anchor="ctr">
+            <a:spAutoFit/>
+          </a:bodyPr>
+          <a:lstStyle/>
+          <a:p>
+            <a:pPr algn="ctr">
+              <a:lnSpc>
+                <a:spcPct val="100000"/>
+              </a:lnSpc>
+            </a:pPr>
+            <a:r>
+              <a:rPr sz="1500" b="1">
+                <a:solidFill>
+                  <a:srgbClr val="FFFFFF"/>
+                </a:solidFill>
+                <a:latin typeface="Malgun Gothic"/>
+              </a:rPr>
+              <a:t>26</a:t>
+            </a:r>
+          </a:p>
+        </p:txBody>
+      </p:sp>
     </p:spTree>
   </p:cSld>
   <p:clrMapOvr>
@@ -23457,7 +23541,7 @@
         </p:nvSpPr>
         <p:spPr>
           <a:xfrm>
-            <a:off x="365760" y="868680"/>
+            <a:off x="987552" y="868680"/>
             <a:ext cx="9144000" cy="457200"/>
           </a:xfrm>
           <a:prstGeom prst="rect">
@@ -23602,6 +23686,89 @@
           </a:graphicData>
         </a:graphic>
       </p:graphicFrame>
+      <p:sp>
+        <p:nvSpPr>
+          <p:cNvPr id="6" name="Rounded Rectangle 5"/>
+          <p:cNvSpPr/>
+          <p:nvPr/>
+        </p:nvSpPr>
+        <p:spPr>
+          <a:xfrm>
+            <a:off x="365760" y="841247"/>
+            <a:ext cx="475488" cy="475488"/>
+          </a:xfrm>
+          <a:prstGeom prst="roundRect">
+            <a:avLst/>
+          </a:prstGeom>
+          <a:solidFill>
+            <a:srgbClr val="4F46E5"/>
+          </a:solidFill>
+          <a:ln>
+            <a:noFill/>
+          </a:ln>
+          <a:effectLst/>
+        </p:spPr>
+        <p:style>
+          <a:lnRef idx="1">
+            <a:schemeClr val="accent1"/>
+          </a:lnRef>
+          <a:fillRef idx="3">
+            <a:schemeClr val="accent1"/>
+          </a:fillRef>
+          <a:effectRef idx="2">
+            <a:schemeClr val="accent1"/>
+          </a:effectRef>
+          <a:fontRef idx="minor">
+            <a:schemeClr val="lt1"/>
+          </a:fontRef>
+        </p:style>
+        <p:txBody>
+          <a:bodyPr rtlCol="0" anchor="ctr"/>
+          <a:lstStyle/>
+          <a:p>
+            <a:pPr algn="ctr"/>
+          </a:p>
+        </p:txBody>
+      </p:sp>
+      <p:sp>
+        <p:nvSpPr>
+          <p:cNvPr id="7" name="TextBox 6"/>
+          <p:cNvSpPr txBox="1"/>
+          <p:nvPr/>
+        </p:nvSpPr>
+        <p:spPr>
+          <a:xfrm>
+            <a:off x="365760" y="841247"/>
+            <a:ext cx="475488" cy="475488"/>
+          </a:xfrm>
+          <a:prstGeom prst="rect">
+            <a:avLst/>
+          </a:prstGeom>
+          <a:noFill/>
+        </p:spPr>
+        <p:txBody>
+          <a:bodyPr wrap="square" anchor="ctr">
+            <a:spAutoFit/>
+          </a:bodyPr>
+          <a:lstStyle/>
+          <a:p>
+            <a:pPr algn="ctr">
+              <a:lnSpc>
+                <a:spcPct val="100000"/>
+              </a:lnSpc>
+            </a:pPr>
+            <a:r>
+              <a:rPr sz="1500" b="1">
+                <a:solidFill>
+                  <a:srgbClr val="FFFFFF"/>
+                </a:solidFill>
+                <a:latin typeface="Malgun Gothic"/>
+              </a:rPr>
+              <a:t>27</a:t>
+            </a:r>
+          </a:p>
+        </p:txBody>
+      </p:sp>
     </p:spTree>
   </p:cSld>
   <p:clrMapOvr>
@@ -24731,7 +24898,7 @@
         </p:nvSpPr>
         <p:spPr>
           <a:xfrm>
-            <a:off x="365760" y="868680"/>
+            <a:off x="987552" y="868680"/>
             <a:ext cx="9144000" cy="457200"/>
           </a:xfrm>
           <a:prstGeom prst="rect">
@@ -25502,6 +25669,89 @@
                 <a:latin typeface="Malgun Gothic"/>
               </a:rPr>
               <a:t>A. Find at-risk students early with the Retention Center's churn-risk/contagion network and intervene via alert-talk/counseling.</a:t>
+            </a:r>
+          </a:p>
+        </p:txBody>
+      </p:sp>
+      <p:sp>
+        <p:nvSpPr>
+          <p:cNvPr id="6" name="Rounded Rectangle 5"/>
+          <p:cNvSpPr/>
+          <p:nvPr/>
+        </p:nvSpPr>
+        <p:spPr>
+          <a:xfrm>
+            <a:off x="365760" y="841247"/>
+            <a:ext cx="475488" cy="475488"/>
+          </a:xfrm>
+          <a:prstGeom prst="roundRect">
+            <a:avLst/>
+          </a:prstGeom>
+          <a:solidFill>
+            <a:srgbClr val="4F46E5"/>
+          </a:solidFill>
+          <a:ln>
+            <a:noFill/>
+          </a:ln>
+          <a:effectLst/>
+        </p:spPr>
+        <p:style>
+          <a:lnRef idx="1">
+            <a:schemeClr val="accent1"/>
+          </a:lnRef>
+          <a:fillRef idx="3">
+            <a:schemeClr val="accent1"/>
+          </a:fillRef>
+          <a:effectRef idx="2">
+            <a:schemeClr val="accent1"/>
+          </a:effectRef>
+          <a:fontRef idx="minor">
+            <a:schemeClr val="lt1"/>
+          </a:fontRef>
+        </p:style>
+        <p:txBody>
+          <a:bodyPr rtlCol="0" anchor="ctr"/>
+          <a:lstStyle/>
+          <a:p>
+            <a:pPr algn="ctr"/>
+          </a:p>
+        </p:txBody>
+      </p:sp>
+      <p:sp>
+        <p:nvSpPr>
+          <p:cNvPr id="7" name="TextBox 6"/>
+          <p:cNvSpPr txBox="1"/>
+          <p:nvPr/>
+        </p:nvSpPr>
+        <p:spPr>
+          <a:xfrm>
+            <a:off x="365760" y="841247"/>
+            <a:ext cx="475488" cy="475488"/>
+          </a:xfrm>
+          <a:prstGeom prst="rect">
+            <a:avLst/>
+          </a:prstGeom>
+          <a:noFill/>
+        </p:spPr>
+        <p:txBody>
+          <a:bodyPr wrap="square" anchor="ctr">
+            <a:spAutoFit/>
+          </a:bodyPr>
+          <a:lstStyle/>
+          <a:p>
+            <a:pPr algn="ctr">
+              <a:lnSpc>
+                <a:spcPct val="100000"/>
+              </a:lnSpc>
+            </a:pPr>
+            <a:r>
+              <a:rPr sz="1500" b="1">
+                <a:solidFill>
+                  <a:srgbClr val="FFFFFF"/>
+                </a:solidFill>
+                <a:latin typeface="Malgun Gothic"/>
+              </a:rPr>
+              <a:t>28</a:t>
             </a:r>
           </a:p>
         </p:txBody>
@@ -25706,7 +25956,7 @@
         </p:nvSpPr>
         <p:spPr>
           <a:xfrm>
-            <a:off x="365760" y="868680"/>
+            <a:off x="987552" y="868680"/>
             <a:ext cx="9144000" cy="457200"/>
           </a:xfrm>
           <a:prstGeom prst="rect">
@@ -26356,6 +26606,89 @@
           </a:prstGeom>
         </p:spPr>
       </p:pic>
+      <p:sp>
+        <p:nvSpPr>
+          <p:cNvPr id="6" name="Rounded Rectangle 5"/>
+          <p:cNvSpPr/>
+          <p:nvPr/>
+        </p:nvSpPr>
+        <p:spPr>
+          <a:xfrm>
+            <a:off x="365760" y="841247"/>
+            <a:ext cx="475488" cy="475488"/>
+          </a:xfrm>
+          <a:prstGeom prst="roundRect">
+            <a:avLst/>
+          </a:prstGeom>
+          <a:solidFill>
+            <a:srgbClr val="4F46E5"/>
+          </a:solidFill>
+          <a:ln>
+            <a:noFill/>
+          </a:ln>
+          <a:effectLst/>
+        </p:spPr>
+        <p:style>
+          <a:lnRef idx="1">
+            <a:schemeClr val="accent1"/>
+          </a:lnRef>
+          <a:fillRef idx="3">
+            <a:schemeClr val="accent1"/>
+          </a:fillRef>
+          <a:effectRef idx="2">
+            <a:schemeClr val="accent1"/>
+          </a:effectRef>
+          <a:fontRef idx="minor">
+            <a:schemeClr val="lt1"/>
+          </a:fontRef>
+        </p:style>
+        <p:txBody>
+          <a:bodyPr rtlCol="0" anchor="ctr"/>
+          <a:lstStyle/>
+          <a:p>
+            <a:pPr algn="ctr"/>
+          </a:p>
+        </p:txBody>
+      </p:sp>
+      <p:sp>
+        <p:nvSpPr>
+          <p:cNvPr id="7" name="TextBox 6"/>
+          <p:cNvSpPr txBox="1"/>
+          <p:nvPr/>
+        </p:nvSpPr>
+        <p:spPr>
+          <a:xfrm>
+            <a:off x="365760" y="841247"/>
+            <a:ext cx="475488" cy="475488"/>
+          </a:xfrm>
+          <a:prstGeom prst="rect">
+            <a:avLst/>
+          </a:prstGeom>
+          <a:noFill/>
+        </p:spPr>
+        <p:txBody>
+          <a:bodyPr wrap="square" anchor="ctr">
+            <a:spAutoFit/>
+          </a:bodyPr>
+          <a:lstStyle/>
+          <a:p>
+            <a:pPr algn="ctr">
+              <a:lnSpc>
+                <a:spcPct val="100000"/>
+              </a:lnSpc>
+            </a:pPr>
+            <a:r>
+              <a:rPr sz="1500" b="1">
+                <a:solidFill>
+                  <a:srgbClr val="FFFFFF"/>
+                </a:solidFill>
+                <a:latin typeface="Malgun Gothic"/>
+              </a:rPr>
+              <a:t>29</a:t>
+            </a:r>
+          </a:p>
+        </p:txBody>
+      </p:sp>
     </p:spTree>
   </p:cSld>
   <p:clrMapOvr>
@@ -26556,7 +26889,7 @@
         </p:nvSpPr>
         <p:spPr>
           <a:xfrm>
-            <a:off x="365760" y="822960"/>
+            <a:off x="987552" y="822960"/>
             <a:ext cx="11430000" cy="457200"/>
           </a:xfrm>
           <a:prstGeom prst="rect">
@@ -27776,6 +28109,89 @@
                 <a:latin typeface="Malgun Gothic"/>
               </a:rPr>
               <a:t>🍊 Good operations come not from fancy features but from 'small daily checks.' Watch your metrics, prevent churn early, and announce policies clearly. The AI Operations Assistant and Retention Center help you do it. Questions? Contact support anytime — cheering on your steadily growing academy! 🍊</a:t>
+            </a:r>
+          </a:p>
+        </p:txBody>
+      </p:sp>
+      <p:sp>
+        <p:nvSpPr>
+          <p:cNvPr id="6" name="Rounded Rectangle 5"/>
+          <p:cNvSpPr/>
+          <p:nvPr/>
+        </p:nvSpPr>
+        <p:spPr>
+          <a:xfrm>
+            <a:off x="365760" y="795528"/>
+            <a:ext cx="475488" cy="475488"/>
+          </a:xfrm>
+          <a:prstGeom prst="roundRect">
+            <a:avLst/>
+          </a:prstGeom>
+          <a:solidFill>
+            <a:srgbClr val="4F46E5"/>
+          </a:solidFill>
+          <a:ln>
+            <a:noFill/>
+          </a:ln>
+          <a:effectLst/>
+        </p:spPr>
+        <p:style>
+          <a:lnRef idx="1">
+            <a:schemeClr val="accent1"/>
+          </a:lnRef>
+          <a:fillRef idx="3">
+            <a:schemeClr val="accent1"/>
+          </a:fillRef>
+          <a:effectRef idx="2">
+            <a:schemeClr val="accent1"/>
+          </a:effectRef>
+          <a:fontRef idx="minor">
+            <a:schemeClr val="lt1"/>
+          </a:fontRef>
+        </p:style>
+        <p:txBody>
+          <a:bodyPr rtlCol="0" anchor="ctr"/>
+          <a:lstStyle/>
+          <a:p>
+            <a:pPr algn="ctr"/>
+          </a:p>
+        </p:txBody>
+      </p:sp>
+      <p:sp>
+        <p:nvSpPr>
+          <p:cNvPr id="7" name="TextBox 6"/>
+          <p:cNvSpPr txBox="1"/>
+          <p:nvPr/>
+        </p:nvSpPr>
+        <p:spPr>
+          <a:xfrm>
+            <a:off x="365760" y="795528"/>
+            <a:ext cx="475488" cy="475488"/>
+          </a:xfrm>
+          <a:prstGeom prst="rect">
+            <a:avLst/>
+          </a:prstGeom>
+          <a:noFill/>
+        </p:spPr>
+        <p:txBody>
+          <a:bodyPr wrap="square" anchor="ctr">
+            <a:spAutoFit/>
+          </a:bodyPr>
+          <a:lstStyle/>
+          <a:p>
+            <a:pPr algn="ctr">
+              <a:lnSpc>
+                <a:spcPct val="100000"/>
+              </a:lnSpc>
+            </a:pPr>
+            <a:r>
+              <a:rPr sz="1500" b="1">
+                <a:solidFill>
+                  <a:srgbClr val="FFFFFF"/>
+                </a:solidFill>
+                <a:latin typeface="Malgun Gothic"/>
+              </a:rPr>
+              <a:t>30</a:t>
             </a:r>
           </a:p>
         </p:txBody>
@@ -28051,6 +28467,1324 @@
                 <a:latin typeface="Malgun Gothic"/>
               </a:rPr>
               <a:t>🌐 www.mangoi.co.kr    📞 1644-0561    ✉ support@mangoi.co.kr</a:t>
+            </a:r>
+          </a:p>
+        </p:txBody>
+      </p:sp>
+    </p:spTree>
+  </p:cSld>
+  <p:clrMapOvr>
+    <a:masterClrMapping/>
+  </p:clrMapOvr>
+</p:sld>
+</file>
+
+<file path=ppt/slides/slide34.xml><?xml version="1.0" encoding="utf-8"?>
+<p:sld xmlns:a="http://schemas.openxmlformats.org/drawingml/2006/main" xmlns:p="http://schemas.openxmlformats.org/presentationml/2006/main" xmlns:r="http://schemas.openxmlformats.org/officeDocument/2006/relationships">
+  <p:cSld>
+    <p:spTree>
+      <p:nvGrpSpPr>
+        <p:cNvPr id="1" name=""/>
+        <p:cNvGrpSpPr/>
+        <p:nvPr/>
+      </p:nvGrpSpPr>
+      <p:grpSpPr/>
+      <p:sp>
+        <p:nvSpPr>
+          <p:cNvPr id="2" name="Rectangle 1"/>
+          <p:cNvSpPr/>
+          <p:nvPr/>
+        </p:nvSpPr>
+        <p:spPr>
+          <a:xfrm>
+            <a:off x="0" y="0"/>
+            <a:ext cx="12191695" cy="566928"/>
+          </a:xfrm>
+          <a:prstGeom prst="rect">
+            <a:avLst/>
+          </a:prstGeom>
+          <a:solidFill>
+            <a:srgbClr val="4F46E5"/>
+          </a:solidFill>
+          <a:ln>
+            <a:noFill/>
+          </a:ln>
+          <a:effectLst/>
+        </p:spPr>
+        <p:style>
+          <a:lnRef idx="1">
+            <a:schemeClr val="accent1"/>
+          </a:lnRef>
+          <a:fillRef idx="3">
+            <a:schemeClr val="accent1"/>
+          </a:fillRef>
+          <a:effectRef idx="2">
+            <a:schemeClr val="accent1"/>
+          </a:effectRef>
+          <a:fontRef idx="minor">
+            <a:schemeClr val="lt1"/>
+          </a:fontRef>
+        </p:style>
+        <p:txBody>
+          <a:bodyPr rtlCol="0" anchor="ctr"/>
+          <a:lstStyle/>
+          <a:p>
+            <a:pPr algn="ctr"/>
+          </a:p>
+        </p:txBody>
+      </p:sp>
+      <p:sp>
+        <p:nvSpPr>
+          <p:cNvPr id="3" name="Rectangle 2"/>
+          <p:cNvSpPr/>
+          <p:nvPr/>
+        </p:nvSpPr>
+        <p:spPr>
+          <a:xfrm>
+            <a:off x="0" y="566928"/>
+            <a:ext cx="12191695" cy="54864"/>
+          </a:xfrm>
+          <a:prstGeom prst="rect">
+            <a:avLst/>
+          </a:prstGeom>
+          <a:solidFill>
+            <a:srgbClr val="FF9F1C"/>
+          </a:solidFill>
+          <a:ln>
+            <a:noFill/>
+          </a:ln>
+          <a:effectLst/>
+        </p:spPr>
+        <p:style>
+          <a:lnRef idx="1">
+            <a:schemeClr val="accent1"/>
+          </a:lnRef>
+          <a:fillRef idx="3">
+            <a:schemeClr val="accent1"/>
+          </a:fillRef>
+          <a:effectRef idx="2">
+            <a:schemeClr val="accent1"/>
+          </a:effectRef>
+          <a:fontRef idx="minor">
+            <a:schemeClr val="lt1"/>
+          </a:fontRef>
+        </p:style>
+        <p:txBody>
+          <a:bodyPr rtlCol="0" anchor="ctr"/>
+          <a:lstStyle/>
+          <a:p>
+            <a:pPr algn="ctr"/>
+          </a:p>
+        </p:txBody>
+      </p:sp>
+      <p:sp>
+        <p:nvSpPr>
+          <p:cNvPr id="4" name="TextBox 3"/>
+          <p:cNvSpPr txBox="1"/>
+          <p:nvPr/>
+        </p:nvSpPr>
+        <p:spPr>
+          <a:xfrm>
+            <a:off x="365760" y="27432"/>
+            <a:ext cx="7315200" cy="502920"/>
+          </a:xfrm>
+          <a:prstGeom prst="rect">
+            <a:avLst/>
+          </a:prstGeom>
+          <a:noFill/>
+        </p:spPr>
+        <p:txBody>
+          <a:bodyPr wrap="square" anchor="ctr">
+            <a:spAutoFit/>
+          </a:bodyPr>
+          <a:lstStyle/>
+          <a:p>
+            <a:pPr algn="l">
+              <a:lnSpc>
+                <a:spcPct val="100000"/>
+              </a:lnSpc>
+            </a:pPr>
+            <a:r>
+              <a:rPr sz="1500" b="1">
+                <a:solidFill>
+                  <a:srgbClr val="FFFFFF"/>
+                </a:solidFill>
+                <a:latin typeface="Malgun Gothic"/>
+              </a:rPr>
+              <a:t>🏫 Mangoi Admin User Guide</a:t>
+            </a:r>
+          </a:p>
+        </p:txBody>
+      </p:sp>
+      <p:sp>
+        <p:nvSpPr>
+          <p:cNvPr id="5" name="TextBox 4"/>
+          <p:cNvSpPr txBox="1"/>
+          <p:nvPr/>
+        </p:nvSpPr>
+        <p:spPr>
+          <a:xfrm>
+            <a:off x="8168335" y="27432"/>
+            <a:ext cx="3657600" cy="502920"/>
+          </a:xfrm>
+          <a:prstGeom prst="rect">
+            <a:avLst/>
+          </a:prstGeom>
+          <a:noFill/>
+        </p:spPr>
+        <p:txBody>
+          <a:bodyPr wrap="square" anchor="ctr">
+            <a:spAutoFit/>
+          </a:bodyPr>
+          <a:lstStyle/>
+          <a:p>
+            <a:pPr algn="r">
+              <a:lnSpc>
+                <a:spcPct val="100000"/>
+              </a:lnSpc>
+            </a:pPr>
+            <a:r>
+              <a:rPr sz="1300" b="1">
+                <a:solidFill>
+                  <a:srgbClr val="F1F5F9"/>
+                </a:solidFill>
+                <a:latin typeface="Malgun Gothic"/>
+              </a:rPr>
+              <a:t>Contents</a:t>
+            </a:r>
+          </a:p>
+        </p:txBody>
+      </p:sp>
+      <p:sp>
+        <p:nvSpPr>
+          <p:cNvPr id="6" name="TextBox 5"/>
+          <p:cNvSpPr txBox="1"/>
+          <p:nvPr/>
+        </p:nvSpPr>
+        <p:spPr>
+          <a:xfrm>
+            <a:off x="365760" y="749808"/>
+            <a:ext cx="7315200" cy="502920"/>
+          </a:xfrm>
+          <a:prstGeom prst="rect">
+            <a:avLst/>
+          </a:prstGeom>
+          <a:noFill/>
+        </p:spPr>
+        <p:txBody>
+          <a:bodyPr wrap="none">
+            <a:spAutoFit/>
+          </a:bodyPr>
+          <a:lstStyle/>
+          <a:p>
+            <a:r>
+              <a:rPr sz="2200" b="1">
+                <a:solidFill>
+                  <a:srgbClr val="1E2340"/>
+                </a:solidFill>
+                <a:latin typeface="Malgun Gothic"/>
+              </a:rPr>
+              <a:t>📑 Contents</a:t>
+            </a:r>
+          </a:p>
+        </p:txBody>
+      </p:sp>
+      <p:sp>
+        <p:nvSpPr>
+          <p:cNvPr id="7" name="TextBox 6"/>
+          <p:cNvSpPr txBox="1"/>
+          <p:nvPr/>
+        </p:nvSpPr>
+        <p:spPr>
+          <a:xfrm>
+            <a:off x="365760" y="1417320"/>
+            <a:ext cx="5500116" cy="5212080"/>
+          </a:xfrm>
+          <a:prstGeom prst="rect">
+            <a:avLst/>
+          </a:prstGeom>
+          <a:noFill/>
+        </p:spPr>
+        <p:txBody>
+          <a:bodyPr wrap="none">
+            <a:spAutoFit/>
+          </a:bodyPr>
+          <a:lstStyle/>
+          <a:p>
+            <a:pPr>
+              <a:spcAft>
+                <a:spcPts val="1080"/>
+              </a:spcAft>
+            </a:pPr>
+            <a:r>
+              <a:rPr sz="1100" b="1">
+                <a:solidFill>
+                  <a:srgbClr val="4F46E5"/>
+                </a:solidFill>
+                <a:latin typeface="Malgun Gothic"/>
+              </a:rPr>
+              <a:t>·   </a:t>
+            </a:r>
+            <a:r>
+              <a:rPr sz="1100">
+                <a:solidFill>
+                  <a:srgbClr val="334155"/>
+                </a:solidFill>
+                <a:latin typeface="Malgun Gothic"/>
+              </a:rPr>
+              <a:t>Introduction</a:t>
+            </a:r>
+            <a:r>
+              <a:rPr sz="950">
+                <a:solidFill>
+                  <a:srgbClr val="94A3B8"/>
+                </a:solidFill>
+                <a:latin typeface="Malgun Gothic"/>
+              </a:rPr>
+              <a:t>   ·  p.3</a:t>
+            </a:r>
+          </a:p>
+          <a:p>
+            <a:pPr>
+              <a:spcAft>
+                <a:spcPts val="1080"/>
+              </a:spcAft>
+            </a:pPr>
+            <a:r>
+              <a:rPr sz="1100" b="1">
+                <a:solidFill>
+                  <a:srgbClr val="4F46E5"/>
+                </a:solidFill>
+                <a:latin typeface="Malgun Gothic"/>
+              </a:rPr>
+              <a:t>01  </a:t>
+            </a:r>
+            <a:r>
+              <a:rPr sz="1100">
+                <a:solidFill>
+                  <a:srgbClr val="334155"/>
+                </a:solidFill>
+                <a:latin typeface="Malgun Gothic"/>
+              </a:rPr>
+              <a:t>🔐 Admin Login &amp; Permissions</a:t>
+            </a:r>
+            <a:r>
+              <a:rPr sz="950">
+                <a:solidFill>
+                  <a:srgbClr val="94A3B8"/>
+                </a:solidFill>
+                <a:latin typeface="Malgun Gothic"/>
+              </a:rPr>
+              <a:t>   ·  p.4</a:t>
+            </a:r>
+          </a:p>
+          <a:p>
+            <a:pPr>
+              <a:spcAft>
+                <a:spcPts val="1080"/>
+              </a:spcAft>
+            </a:pPr>
+            <a:r>
+              <a:rPr sz="1100" b="1">
+                <a:solidFill>
+                  <a:srgbClr val="4F46E5"/>
+                </a:solidFill>
+                <a:latin typeface="Malgun Gothic"/>
+              </a:rPr>
+              <a:t>02  </a:t>
+            </a:r>
+            <a:r>
+              <a:rPr sz="1100">
+                <a:solidFill>
+                  <a:srgbClr val="334155"/>
+                </a:solidFill>
+                <a:latin typeface="Malgun Gothic"/>
+              </a:rPr>
+              <a:t>🏠 Dashboard &amp; Feature Search</a:t>
+            </a:r>
+            <a:r>
+              <a:rPr sz="950">
+                <a:solidFill>
+                  <a:srgbClr val="94A3B8"/>
+                </a:solidFill>
+                <a:latin typeface="Malgun Gothic"/>
+              </a:rPr>
+              <a:t>   ·  p.5</a:t>
+            </a:r>
+          </a:p>
+          <a:p>
+            <a:pPr>
+              <a:spcAft>
+                <a:spcPts val="1080"/>
+              </a:spcAft>
+            </a:pPr>
+            <a:r>
+              <a:rPr sz="1100" b="1">
+                <a:solidFill>
+                  <a:srgbClr val="4F46E5"/>
+                </a:solidFill>
+                <a:latin typeface="Malgun Gothic"/>
+              </a:rPr>
+              <a:t>03  </a:t>
+            </a:r>
+            <a:r>
+              <a:rPr sz="1100">
+                <a:solidFill>
+                  <a:srgbClr val="334155"/>
+                </a:solidFill>
+                <a:latin typeface="Malgun Gothic"/>
+              </a:rPr>
+              <a:t>🤖 AI Operations Assistant</a:t>
+            </a:r>
+            <a:r>
+              <a:rPr sz="950">
+                <a:solidFill>
+                  <a:srgbClr val="94A3B8"/>
+                </a:solidFill>
+                <a:latin typeface="Malgun Gothic"/>
+              </a:rPr>
+              <a:t>   ·  p.6</a:t>
+            </a:r>
+          </a:p>
+          <a:p>
+            <a:pPr>
+              <a:spcAft>
+                <a:spcPts val="1080"/>
+              </a:spcAft>
+            </a:pPr>
+            <a:r>
+              <a:rPr sz="1100" b="1">
+                <a:solidFill>
+                  <a:srgbClr val="4F46E5"/>
+                </a:solidFill>
+                <a:latin typeface="Malgun Gothic"/>
+              </a:rPr>
+              <a:t>04  </a:t>
+            </a:r>
+            <a:r>
+              <a:rPr sz="1100">
+                <a:solidFill>
+                  <a:srgbClr val="334155"/>
+                </a:solidFill>
+                <a:latin typeface="Malgun Gothic"/>
+              </a:rPr>
+              <a:t>🎥 Understand Lesson Entry</a:t>
+            </a:r>
+            <a:r>
+              <a:rPr sz="950">
+                <a:solidFill>
+                  <a:srgbClr val="94A3B8"/>
+                </a:solidFill>
+                <a:latin typeface="Malgun Gothic"/>
+              </a:rPr>
+              <a:t>   ·  p.7</a:t>
+            </a:r>
+          </a:p>
+          <a:p>
+            <a:pPr>
+              <a:spcAft>
+                <a:spcPts val="1080"/>
+              </a:spcAft>
+            </a:pPr>
+            <a:r>
+              <a:rPr sz="1100" b="1">
+                <a:solidFill>
+                  <a:srgbClr val="4F46E5"/>
+                </a:solidFill>
+                <a:latin typeface="Malgun Gothic"/>
+              </a:rPr>
+              <a:t>05  </a:t>
+            </a:r>
+            <a:r>
+              <a:rPr sz="1100">
+                <a:solidFill>
+                  <a:srgbClr val="334155"/>
+                </a:solidFill>
+                <a:latin typeface="Malgun Gothic"/>
+              </a:rPr>
+              <a:t>🖥️ Understand the Classroom …</a:t>
+            </a:r>
+            <a:r>
+              <a:rPr sz="950">
+                <a:solidFill>
+                  <a:srgbClr val="94A3B8"/>
+                </a:solidFill>
+                <a:latin typeface="Malgun Gothic"/>
+              </a:rPr>
+              <a:t>   ·  p.8</a:t>
+            </a:r>
+          </a:p>
+          <a:p>
+            <a:pPr>
+              <a:spcAft>
+                <a:spcPts val="1080"/>
+              </a:spcAft>
+            </a:pPr>
+            <a:r>
+              <a:rPr sz="1100" b="1">
+                <a:solidFill>
+                  <a:srgbClr val="4F46E5"/>
+                </a:solidFill>
+                <a:latin typeface="Malgun Gothic"/>
+              </a:rPr>
+              <a:t>06  </a:t>
+            </a:r>
+            <a:r>
+              <a:rPr sz="1100">
+                <a:solidFill>
+                  <a:srgbClr val="334155"/>
+                </a:solidFill>
+                <a:latin typeface="Malgun Gothic"/>
+              </a:rPr>
+              <a:t>🧰 Understand the Classroom T…</a:t>
+            </a:r>
+            <a:r>
+              <a:rPr sz="950">
+                <a:solidFill>
+                  <a:srgbClr val="94A3B8"/>
+                </a:solidFill>
+                <a:latin typeface="Malgun Gothic"/>
+              </a:rPr>
+              <a:t>   ·  p.9</a:t>
+            </a:r>
+          </a:p>
+          <a:p>
+            <a:pPr>
+              <a:spcAft>
+                <a:spcPts val="1080"/>
+              </a:spcAft>
+            </a:pPr>
+            <a:r>
+              <a:rPr sz="1100" b="1">
+                <a:solidFill>
+                  <a:srgbClr val="4F46E5"/>
+                </a:solidFill>
+                <a:latin typeface="Malgun Gothic"/>
+              </a:rPr>
+              <a:t>07  </a:t>
+            </a:r>
+            <a:r>
+              <a:rPr sz="1100">
+                <a:solidFill>
+                  <a:srgbClr val="334155"/>
+                </a:solidFill>
+                <a:latin typeface="Malgun Gothic"/>
+              </a:rPr>
+              <a:t>🌟 In-class Praise Points (gi…</a:t>
+            </a:r>
+            <a:r>
+              <a:rPr sz="950">
+                <a:solidFill>
+                  <a:srgbClr val="94A3B8"/>
+                </a:solidFill>
+                <a:latin typeface="Malgun Gothic"/>
+              </a:rPr>
+              <a:t>   ·  p.10</a:t>
+            </a:r>
+          </a:p>
+          <a:p>
+            <a:pPr>
+              <a:spcAft>
+                <a:spcPts val="1080"/>
+              </a:spcAft>
+            </a:pPr>
+            <a:r>
+              <a:rPr sz="1100" b="1">
+                <a:solidFill>
+                  <a:srgbClr val="4F46E5"/>
+                </a:solidFill>
+                <a:latin typeface="Malgun Gothic"/>
+              </a:rPr>
+              <a:t>08  </a:t>
+            </a:r>
+            <a:r>
+              <a:rPr sz="1100">
+                <a:solidFill>
+                  <a:srgbClr val="334155"/>
+                </a:solidFill>
+                <a:latin typeface="Malgun Gothic"/>
+              </a:rPr>
+              <a:t>👩‍🏫 Teacher Management</a:t>
+            </a:r>
+            <a:r>
+              <a:rPr sz="950">
+                <a:solidFill>
+                  <a:srgbClr val="94A3B8"/>
+                </a:solidFill>
+                <a:latin typeface="Malgun Gothic"/>
+              </a:rPr>
+              <a:t>   ·  p.11</a:t>
+            </a:r>
+          </a:p>
+          <a:p>
+            <a:pPr>
+              <a:spcAft>
+                <a:spcPts val="1080"/>
+              </a:spcAft>
+            </a:pPr>
+            <a:r>
+              <a:rPr sz="1100" b="1">
+                <a:solidFill>
+                  <a:srgbClr val="4F46E5"/>
+                </a:solidFill>
+                <a:latin typeface="Malgun Gothic"/>
+              </a:rPr>
+              <a:t>09  </a:t>
+            </a:r>
+            <a:r>
+              <a:rPr sz="1100">
+                <a:solidFill>
+                  <a:srgbClr val="334155"/>
+                </a:solidFill>
+                <a:latin typeface="Malgun Gothic"/>
+              </a:rPr>
+              <a:t>💳 Accounting · Points</a:t>
+            </a:r>
+            <a:r>
+              <a:rPr sz="950">
+                <a:solidFill>
+                  <a:srgbClr val="94A3B8"/>
+                </a:solidFill>
+                <a:latin typeface="Malgun Gothic"/>
+              </a:rPr>
+              <a:t>   ·  p.12</a:t>
+            </a:r>
+          </a:p>
+          <a:p>
+            <a:pPr>
+              <a:spcAft>
+                <a:spcPts val="1080"/>
+              </a:spcAft>
+            </a:pPr>
+            <a:r>
+              <a:rPr sz="1100" b="1">
+                <a:solidFill>
+                  <a:srgbClr val="4F46E5"/>
+                </a:solidFill>
+                <a:latin typeface="Malgun Gothic"/>
+              </a:rPr>
+              <a:t>10  </a:t>
+            </a:r>
+            <a:r>
+              <a:rPr sz="1100">
+                <a:solidFill>
+                  <a:srgbClr val="334155"/>
+                </a:solidFill>
+                <a:latin typeface="Malgun Gothic"/>
+              </a:rPr>
+              <a:t>🎁 Points &amp; Reward Policy</a:t>
+            </a:r>
+            <a:r>
+              <a:rPr sz="950">
+                <a:solidFill>
+                  <a:srgbClr val="94A3B8"/>
+                </a:solidFill>
+                <a:latin typeface="Malgun Gothic"/>
+              </a:rPr>
+              <a:t>   ·  p.13</a:t>
+            </a:r>
+          </a:p>
+          <a:p>
+            <a:pPr>
+              <a:spcAft>
+                <a:spcPts val="1080"/>
+              </a:spcAft>
+            </a:pPr>
+            <a:r>
+              <a:rPr sz="1100" b="1">
+                <a:solidFill>
+                  <a:srgbClr val="4F46E5"/>
+                </a:solidFill>
+                <a:latin typeface="Malgun Gothic"/>
+              </a:rPr>
+              <a:t>11  </a:t>
+            </a:r>
+            <a:r>
+              <a:rPr sz="1100">
+                <a:solidFill>
+                  <a:srgbClr val="334155"/>
+                </a:solidFill>
+                <a:latin typeface="Malgun Gothic"/>
+              </a:rPr>
+              <a:t>↩️ Refund Policy &amp; Processing</a:t>
+            </a:r>
+            <a:r>
+              <a:rPr sz="950">
+                <a:solidFill>
+                  <a:srgbClr val="94A3B8"/>
+                </a:solidFill>
+                <a:latin typeface="Malgun Gothic"/>
+              </a:rPr>
+              <a:t>   ·  p.14</a:t>
+            </a:r>
+          </a:p>
+          <a:p>
+            <a:pPr>
+              <a:spcAft>
+                <a:spcPts val="1080"/>
+              </a:spcAft>
+            </a:pPr>
+            <a:r>
+              <a:rPr sz="1100" b="1">
+                <a:solidFill>
+                  <a:srgbClr val="4F46E5"/>
+                </a:solidFill>
+                <a:latin typeface="Malgun Gothic"/>
+              </a:rPr>
+              <a:t>12  </a:t>
+            </a:r>
+            <a:r>
+              <a:rPr sz="1100">
+                <a:solidFill>
+                  <a:srgbClr val="334155"/>
+                </a:solidFill>
+                <a:latin typeface="Malgun Gothic"/>
+              </a:rPr>
+              <a:t>🧑‍🎓 Student · Parent Managem…</a:t>
+            </a:r>
+            <a:r>
+              <a:rPr sz="950">
+                <a:solidFill>
+                  <a:srgbClr val="94A3B8"/>
+                </a:solidFill>
+                <a:latin typeface="Malgun Gothic"/>
+              </a:rPr>
+              <a:t>   ·  p.15</a:t>
+            </a:r>
+          </a:p>
+          <a:p>
+            <a:pPr>
+              <a:spcAft>
+                <a:spcPts val="1080"/>
+              </a:spcAft>
+            </a:pPr>
+            <a:r>
+              <a:rPr sz="1100" b="1">
+                <a:solidFill>
+                  <a:srgbClr val="4F46E5"/>
+                </a:solidFill>
+                <a:latin typeface="Malgun Gothic"/>
+              </a:rPr>
+              <a:t>13  </a:t>
+            </a:r>
+            <a:r>
+              <a:rPr sz="1100">
+                <a:solidFill>
+                  <a:srgbClr val="334155"/>
+                </a:solidFill>
+                <a:latin typeface="Malgun Gothic"/>
+              </a:rPr>
+              <a:t>👨‍👩‍👧 Parent My-Page</a:t>
+            </a:r>
+            <a:r>
+              <a:rPr sz="950">
+                <a:solidFill>
+                  <a:srgbClr val="94A3B8"/>
+                </a:solidFill>
+                <a:latin typeface="Malgun Gothic"/>
+              </a:rPr>
+              <a:t>   ·  p.16</a:t>
+            </a:r>
+          </a:p>
+          <a:p>
+            <a:pPr>
+              <a:spcAft>
+                <a:spcPts val="1080"/>
+              </a:spcAft>
+            </a:pPr>
+            <a:r>
+              <a:rPr sz="1100" b="1">
+                <a:solidFill>
+                  <a:srgbClr val="4F46E5"/>
+                </a:solidFill>
+                <a:latin typeface="Malgun Gothic"/>
+              </a:rPr>
+              <a:t>14  </a:t>
+            </a:r>
+            <a:r>
+              <a:rPr sz="1100">
+                <a:solidFill>
+                  <a:srgbClr val="334155"/>
+                </a:solidFill>
+                <a:latin typeface="Malgun Gothic"/>
+              </a:rPr>
+              <a:t>📅 Booking Management</a:t>
+            </a:r>
+            <a:r>
+              <a:rPr sz="950">
+                <a:solidFill>
+                  <a:srgbClr val="94A3B8"/>
+                </a:solidFill>
+                <a:latin typeface="Malgun Gothic"/>
+              </a:rPr>
+              <a:t>   ·  p.17</a:t>
+            </a:r>
+          </a:p>
+          <a:p>
+            <a:pPr>
+              <a:spcAft>
+                <a:spcPts val="1080"/>
+              </a:spcAft>
+            </a:pPr>
+            <a:r>
+              <a:rPr sz="1100" b="1">
+                <a:solidFill>
+                  <a:srgbClr val="4F46E5"/>
+                </a:solidFill>
+                <a:latin typeface="Malgun Gothic"/>
+              </a:rPr>
+              <a:t>15  </a:t>
+            </a:r>
+            <a:r>
+              <a:rPr sz="1100">
+                <a:solidFill>
+                  <a:srgbClr val="334155"/>
+                </a:solidFill>
+                <a:latin typeface="Malgun Gothic"/>
+              </a:rPr>
+              <a:t>🔄 Postpone Management</a:t>
+            </a:r>
+            <a:r>
+              <a:rPr sz="950">
+                <a:solidFill>
+                  <a:srgbClr val="94A3B8"/>
+                </a:solidFill>
+                <a:latin typeface="Malgun Gothic"/>
+              </a:rPr>
+              <a:t>   ·  p.18</a:t>
+            </a:r>
+          </a:p>
+        </p:txBody>
+      </p:sp>
+      <p:sp>
+        <p:nvSpPr>
+          <p:cNvPr id="8" name="TextBox 7"/>
+          <p:cNvSpPr txBox="1"/>
+          <p:nvPr/>
+        </p:nvSpPr>
+        <p:spPr>
+          <a:xfrm>
+            <a:off x="6094476" y="1417320"/>
+            <a:ext cx="5500116" cy="5212080"/>
+          </a:xfrm>
+          <a:prstGeom prst="rect">
+            <a:avLst/>
+          </a:prstGeom>
+          <a:noFill/>
+        </p:spPr>
+        <p:txBody>
+          <a:bodyPr wrap="none">
+            <a:spAutoFit/>
+          </a:bodyPr>
+          <a:lstStyle/>
+          <a:p>
+            <a:pPr>
+              <a:spcAft>
+                <a:spcPts val="1080"/>
+              </a:spcAft>
+            </a:pPr>
+            <a:r>
+              <a:rPr sz="1100" b="1">
+                <a:solidFill>
+                  <a:srgbClr val="4F46E5"/>
+                </a:solidFill>
+                <a:latin typeface="Malgun Gothic"/>
+              </a:rPr>
+              <a:t>16  </a:t>
+            </a:r>
+            <a:r>
+              <a:rPr sz="1100">
+                <a:solidFill>
+                  <a:srgbClr val="334155"/>
+                </a:solidFill>
+                <a:latin typeface="Malgun Gothic"/>
+              </a:rPr>
+              <a:t>📚 Content · Curriculum</a:t>
+            </a:r>
+            <a:r>
+              <a:rPr sz="950">
+                <a:solidFill>
+                  <a:srgbClr val="94A3B8"/>
+                </a:solidFill>
+                <a:latin typeface="Malgun Gothic"/>
+              </a:rPr>
+              <a:t>   ·  p.19</a:t>
+            </a:r>
+          </a:p>
+          <a:p>
+            <a:pPr>
+              <a:spcAft>
+                <a:spcPts val="1080"/>
+              </a:spcAft>
+            </a:pPr>
+            <a:r>
+              <a:rPr sz="1100" b="1">
+                <a:solidFill>
+                  <a:srgbClr val="4F46E5"/>
+                </a:solidFill>
+                <a:latin typeface="Malgun Gothic"/>
+              </a:rPr>
+              <a:t>17  </a:t>
+            </a:r>
+            <a:r>
+              <a:rPr sz="1100">
+                <a:solidFill>
+                  <a:srgbClr val="334155"/>
+                </a:solidFill>
+                <a:latin typeface="Malgun Gothic"/>
+              </a:rPr>
+              <a:t>🧲 Retention Center</a:t>
+            </a:r>
+            <a:r>
+              <a:rPr sz="950">
+                <a:solidFill>
+                  <a:srgbClr val="94A3B8"/>
+                </a:solidFill>
+                <a:latin typeface="Malgun Gothic"/>
+              </a:rPr>
+              <a:t>   ·  p.20</a:t>
+            </a:r>
+          </a:p>
+          <a:p>
+            <a:pPr>
+              <a:spcAft>
+                <a:spcPts val="1080"/>
+              </a:spcAft>
+            </a:pPr>
+            <a:r>
+              <a:rPr sz="1100" b="1">
+                <a:solidFill>
+                  <a:srgbClr val="4F46E5"/>
+                </a:solidFill>
+                <a:latin typeface="Malgun Gothic"/>
+              </a:rPr>
+              <a:t>18  </a:t>
+            </a:r>
+            <a:r>
+              <a:rPr sz="1100">
+                <a:solidFill>
+                  <a:srgbClr val="334155"/>
+                </a:solidFill>
+                <a:latin typeface="Malgun Gothic"/>
+              </a:rPr>
+              <a:t>🌳 Org Settlement · Monthly R…</a:t>
+            </a:r>
+            <a:r>
+              <a:rPr sz="950">
+                <a:solidFill>
+                  <a:srgbClr val="94A3B8"/>
+                </a:solidFill>
+                <a:latin typeface="Malgun Gothic"/>
+              </a:rPr>
+              <a:t>   ·  p.21</a:t>
+            </a:r>
+          </a:p>
+          <a:p>
+            <a:pPr>
+              <a:spcAft>
+                <a:spcPts val="1080"/>
+              </a:spcAft>
+            </a:pPr>
+            <a:r>
+              <a:rPr sz="1100" b="1">
+                <a:solidFill>
+                  <a:srgbClr val="4F46E5"/>
+                </a:solidFill>
+                <a:latin typeface="Malgun Gothic"/>
+              </a:rPr>
+              <a:t>19  </a:t>
+            </a:r>
+            <a:r>
+              <a:rPr sz="1100">
+                <a:solidFill>
+                  <a:srgbClr val="334155"/>
+                </a:solidFill>
+                <a:latin typeface="Malgun Gothic"/>
+              </a:rPr>
+              <a:t>🎧 Support · FAQ Operations</a:t>
+            </a:r>
+            <a:r>
+              <a:rPr sz="950">
+                <a:solidFill>
+                  <a:srgbClr val="94A3B8"/>
+                </a:solidFill>
+                <a:latin typeface="Malgun Gothic"/>
+              </a:rPr>
+              <a:t>   ·  p.22</a:t>
+            </a:r>
+          </a:p>
+          <a:p>
+            <a:pPr>
+              <a:spcAft>
+                <a:spcPts val="1080"/>
+              </a:spcAft>
+            </a:pPr>
+            <a:r>
+              <a:rPr sz="1100" b="1">
+                <a:solidFill>
+                  <a:srgbClr val="4F46E5"/>
+                </a:solidFill>
+                <a:latin typeface="Malgun Gothic"/>
+              </a:rPr>
+              <a:t>20  </a:t>
+            </a:r>
+            <a:r>
+              <a:rPr sz="1100">
+                <a:solidFill>
+                  <a:srgbClr val="334155"/>
+                </a:solidFill>
+                <a:latin typeface="Malgun Gothic"/>
+              </a:rPr>
+              <a:t>🕐 Korea·Philippines Dual Clo…</a:t>
+            </a:r>
+            <a:r>
+              <a:rPr sz="950">
+                <a:solidFill>
+                  <a:srgbClr val="94A3B8"/>
+                </a:solidFill>
+                <a:latin typeface="Malgun Gothic"/>
+              </a:rPr>
+              <a:t>   ·  p.23</a:t>
+            </a:r>
+          </a:p>
+          <a:p>
+            <a:pPr>
+              <a:spcAft>
+                <a:spcPts val="1080"/>
+              </a:spcAft>
+            </a:pPr>
+            <a:r>
+              <a:rPr sz="1100" b="1">
+                <a:solidFill>
+                  <a:srgbClr val="4F46E5"/>
+                </a:solidFill>
+                <a:latin typeface="Malgun Gothic"/>
+              </a:rPr>
+              <a:t>21  </a:t>
+            </a:r>
+            <a:r>
+              <a:rPr sz="1100">
+                <a:solidFill>
+                  <a:srgbClr val="334155"/>
+                </a:solidFill>
+                <a:latin typeface="Malgun Gothic"/>
+              </a:rPr>
+              <a:t>🇨🇳 Chinese Pronunciation Coa…</a:t>
+            </a:r>
+            <a:r>
+              <a:rPr sz="950">
+                <a:solidFill>
+                  <a:srgbClr val="94A3B8"/>
+                </a:solidFill>
+                <a:latin typeface="Malgun Gothic"/>
+              </a:rPr>
+              <a:t>   ·  p.24</a:t>
+            </a:r>
+          </a:p>
+          <a:p>
+            <a:pPr>
+              <a:spcAft>
+                <a:spcPts val="1080"/>
+              </a:spcAft>
+            </a:pPr>
+            <a:r>
+              <a:rPr sz="1100" b="1">
+                <a:solidFill>
+                  <a:srgbClr val="4F46E5"/>
+                </a:solidFill>
+                <a:latin typeface="Malgun Gothic"/>
+              </a:rPr>
+              <a:t>22  </a:t>
+            </a:r>
+            <a:r>
+              <a:rPr sz="1100">
+                <a:solidFill>
+                  <a:srgbClr val="334155"/>
+                </a:solidFill>
+                <a:latin typeface="Malgun Gothic"/>
+              </a:rPr>
+              <a:t>📢 Notice Studio (Poster + Po…</a:t>
+            </a:r>
+            <a:r>
+              <a:rPr sz="950">
+                <a:solidFill>
+                  <a:srgbClr val="94A3B8"/>
+                </a:solidFill>
+                <a:latin typeface="Malgun Gothic"/>
+              </a:rPr>
+              <a:t>   ·  p.25</a:t>
+            </a:r>
+          </a:p>
+          <a:p>
+            <a:pPr>
+              <a:spcAft>
+                <a:spcPts val="1080"/>
+              </a:spcAft>
+            </a:pPr>
+            <a:r>
+              <a:rPr sz="1100" b="1">
+                <a:solidFill>
+                  <a:srgbClr val="4F46E5"/>
+                </a:solidFill>
+                <a:latin typeface="Malgun Gothic"/>
+              </a:rPr>
+              <a:t>23  </a:t>
+            </a:r>
+            <a:r>
+              <a:rPr sz="1100">
+                <a:solidFill>
+                  <a:srgbClr val="334155"/>
+                </a:solidFill>
+                <a:latin typeface="Malgun Gothic"/>
+              </a:rPr>
+              <a:t>🤖 Command the AI Operations …</a:t>
+            </a:r>
+            <a:r>
+              <a:rPr sz="950">
+                <a:solidFill>
+                  <a:srgbClr val="94A3B8"/>
+                </a:solidFill>
+                <a:latin typeface="Malgun Gothic"/>
+              </a:rPr>
+              <a:t>   ·  p.26</a:t>
+            </a:r>
+          </a:p>
+          <a:p>
+            <a:pPr>
+              <a:spcAft>
+                <a:spcPts val="1080"/>
+              </a:spcAft>
+            </a:pPr>
+            <a:r>
+              <a:rPr sz="1100" b="1">
+                <a:solidFill>
+                  <a:srgbClr val="4F46E5"/>
+                </a:solidFill>
+                <a:latin typeface="Malgun Gothic"/>
+              </a:rPr>
+              <a:t>24  </a:t>
+            </a:r>
+            <a:r>
+              <a:rPr sz="1100">
+                <a:solidFill>
+                  <a:srgbClr val="334155"/>
+                </a:solidFill>
+                <a:latin typeface="Malgun Gothic"/>
+              </a:rPr>
+              <a:t>📔 Student Voice-Diary Monitor</a:t>
+            </a:r>
+            <a:r>
+              <a:rPr sz="950">
+                <a:solidFill>
+                  <a:srgbClr val="94A3B8"/>
+                </a:solidFill>
+                <a:latin typeface="Malgun Gothic"/>
+              </a:rPr>
+              <a:t>   ·  p.27</a:t>
+            </a:r>
+          </a:p>
+          <a:p>
+            <a:pPr>
+              <a:spcAft>
+                <a:spcPts val="1080"/>
+              </a:spcAft>
+            </a:pPr>
+            <a:r>
+              <a:rPr sz="1100" b="1">
+                <a:solidFill>
+                  <a:srgbClr val="4F46E5"/>
+                </a:solidFill>
+                <a:latin typeface="Malgun Gothic"/>
+              </a:rPr>
+              <a:t>25  </a:t>
+            </a:r>
+            <a:r>
+              <a:rPr sz="1100">
+                <a:solidFill>
+                  <a:srgbClr val="334155"/>
+                </a:solidFill>
+                <a:latin typeface="Malgun Gothic"/>
+              </a:rPr>
+              <a:t>🤖 Teacher AI-Coaching Review…</a:t>
+            </a:r>
+            <a:r>
+              <a:rPr sz="950">
+                <a:solidFill>
+                  <a:srgbClr val="94A3B8"/>
+                </a:solidFill>
+                <a:latin typeface="Malgun Gothic"/>
+              </a:rPr>
+              <a:t>   ·  p.28</a:t>
+            </a:r>
+          </a:p>
+          <a:p>
+            <a:pPr>
+              <a:spcAft>
+                <a:spcPts val="1080"/>
+              </a:spcAft>
+            </a:pPr>
+            <a:r>
+              <a:rPr sz="1100" b="1">
+                <a:solidFill>
+                  <a:srgbClr val="4F46E5"/>
+                </a:solidFill>
+                <a:latin typeface="Malgun Gothic"/>
+              </a:rPr>
+              <a:t>26  </a:t>
+            </a:r>
+            <a:r>
+              <a:rPr sz="1100">
+                <a:solidFill>
+                  <a:srgbClr val="334155"/>
+                </a:solidFill>
+                <a:latin typeface="Malgun Gothic"/>
+              </a:rPr>
+              <a:t>Admin Feature Categories</a:t>
+            </a:r>
+            <a:r>
+              <a:rPr sz="950">
+                <a:solidFill>
+                  <a:srgbClr val="94A3B8"/>
+                </a:solidFill>
+                <a:latin typeface="Malgun Gothic"/>
+              </a:rPr>
+              <a:t>   ·  p.29</a:t>
+            </a:r>
+          </a:p>
+          <a:p>
+            <a:pPr>
+              <a:spcAft>
+                <a:spcPts val="1080"/>
+              </a:spcAft>
+            </a:pPr>
+            <a:r>
+              <a:rPr sz="1100" b="1">
+                <a:solidFill>
+                  <a:srgbClr val="4F46E5"/>
+                </a:solidFill>
+                <a:latin typeface="Malgun Gothic"/>
+              </a:rPr>
+              <a:t>27  </a:t>
+            </a:r>
+            <a:r>
+              <a:rPr sz="1100">
+                <a:solidFill>
+                  <a:srgbClr val="334155"/>
+                </a:solidFill>
+                <a:latin typeface="Malgun Gothic"/>
+              </a:rPr>
+              <a:t>Data at a Glance</a:t>
+            </a:r>
+            <a:r>
+              <a:rPr sz="950">
+                <a:solidFill>
+                  <a:srgbClr val="94A3B8"/>
+                </a:solidFill>
+                <a:latin typeface="Malgun Gothic"/>
+              </a:rPr>
+              <a:t>   ·  p.30</a:t>
+            </a:r>
+          </a:p>
+          <a:p>
+            <a:pPr>
+              <a:spcAft>
+                <a:spcPts val="1080"/>
+              </a:spcAft>
+            </a:pPr>
+            <a:r>
+              <a:rPr sz="1100" b="1">
+                <a:solidFill>
+                  <a:srgbClr val="4F46E5"/>
+                </a:solidFill>
+                <a:latin typeface="Malgun Gothic"/>
+              </a:rPr>
+              <a:t>28  </a:t>
+            </a:r>
+            <a:r>
+              <a:rPr sz="1100">
+                <a:solidFill>
+                  <a:srgbClr val="334155"/>
+                </a:solidFill>
+                <a:latin typeface="Malgun Gothic"/>
+              </a:rPr>
+              <a:t>Frequently Asked Questions (…</a:t>
+            </a:r>
+            <a:r>
+              <a:rPr sz="950">
+                <a:solidFill>
+                  <a:srgbClr val="94A3B8"/>
+                </a:solidFill>
+                <a:latin typeface="Malgun Gothic"/>
+              </a:rPr>
+              <a:t>   ·  p.31</a:t>
+            </a:r>
+          </a:p>
+          <a:p>
+            <a:pPr>
+              <a:spcAft>
+                <a:spcPts val="1080"/>
+              </a:spcAft>
+            </a:pPr>
+            <a:r>
+              <a:rPr sz="1100" b="1">
+                <a:solidFill>
+                  <a:srgbClr val="4F46E5"/>
+                </a:solidFill>
+                <a:latin typeface="Malgun Gothic"/>
+              </a:rPr>
+              <a:t>29  </a:t>
+            </a:r>
+            <a:r>
+              <a:rPr sz="1100">
+                <a:solidFill>
+                  <a:srgbClr val="334155"/>
+                </a:solidFill>
+                <a:latin typeface="Malgun Gothic"/>
+              </a:rPr>
+              <a:t>Daily Operations Checklist</a:t>
+            </a:r>
+            <a:r>
+              <a:rPr sz="950">
+                <a:solidFill>
+                  <a:srgbClr val="94A3B8"/>
+                </a:solidFill>
+                <a:latin typeface="Malgun Gothic"/>
+              </a:rPr>
+              <a:t>   ·  p.32</a:t>
+            </a:r>
+          </a:p>
+          <a:p>
+            <a:pPr>
+              <a:spcAft>
+                <a:spcPts val="1080"/>
+              </a:spcAft>
+            </a:pPr>
+            <a:r>
+              <a:rPr sz="1100" b="1">
+                <a:solidFill>
+                  <a:srgbClr val="4F46E5"/>
+                </a:solidFill>
+                <a:latin typeface="Malgun Gothic"/>
+              </a:rPr>
+              <a:t>30  </a:t>
+            </a:r>
+            <a:r>
+              <a:rPr sz="1100">
+                <a:solidFill>
+                  <a:srgbClr val="334155"/>
+                </a:solidFill>
+                <a:latin typeface="Malgun Gothic"/>
+              </a:rPr>
+              <a:t>Conclusion · A Practical Gui…</a:t>
+            </a:r>
+            <a:r>
+              <a:rPr sz="950">
+                <a:solidFill>
+                  <a:srgbClr val="94A3B8"/>
+                </a:solidFill>
+                <a:latin typeface="Malgun Gothic"/>
+              </a:rPr>
+              <a:t>   ·  p.33</a:t>
             </a:r>
           </a:p>
         </p:txBody>

</xml_diff>